<commit_message>
Final build round: kit fixes, exhibits, gates, native charts (P27), 14 devices, all engine diagram types, library scrub; DL31 retired
Verified: 539 unit tests OK; run_all --negatives exit 0; selftest OK; build_archetypes --check OK; example_build,
example_epic, example_arch, example_arch_topology, example_arch_flow, example_arch_seq, example_charts and
example_exhibits each pass all 27 implemented gates; device library (44) passes its 9 library gates.

Co-Authored-By: Claude Opus 5.5 (1M context) <noreply@anthropic.com>
</commit_message>
<xml_diff>
--- a/kit/assets/base-std.pptx
+++ b/kit/assets/base-std.pptx
@@ -586,10 +586,10 @@
         <a:srgbClr val="00A0E9"/>
       </a:accent3>
       <a:accent4>
-        <a:srgbClr val="F38B1F"/>
+        <a:srgbClr val="A6A6A6"/>
       </a:accent4>
       <a:accent5>
-        <a:srgbClr val="4EA347"/>
+        <a:srgbClr val="D9D9D9"/>
       </a:accent5>
       <a:accent6>
         <a:srgbClr val="6B7983"/>

</xml_diff>